<commit_message>
Polish deck visuals after render review
Co-authored-by: Mohamed  <garlobrian52@users.noreply.github.com>
</commit_message>
<xml_diff>
--- a/deliverables/Apple_FY2025_Environmental_Progress_Business_Sales_Driver.pptx
+++ b/deliverables/Apple_FY2025_Environmental_Progress_Business_Sales_Driver.pptx
@@ -2671,12 +2671,14 @@
           <p:nvPr/>
         </p:nvSpPr>
         <p:spPr>
-          <a:xfrm rot="5400000">
+          <a:xfrm>
             <a:off x="3273552" y="5522976"/>
-            <a:ext cx="5650992" cy="329184"/>
-          </a:xfrm>
-          <a:prstGeom prst="chevron">
-            <a:avLst/>
+            <a:ext cx="5650992" cy="246888"/>
+          </a:xfrm>
+          <a:prstGeom prst="roundRect">
+            <a:avLst>
+              <a:gd name="adj" fmla="val 11111"/>
+            </a:avLst>
           </a:prstGeom>
           <a:solidFill>
             <a:srgbClr val="C5CAC7"/>
@@ -5782,7 +5784,7 @@
         </p:nvSpPr>
         <p:spPr>
           <a:xfrm>
-            <a:off x="9061704" y="1389888"/>
+            <a:off x="9061704" y="1472184"/>
             <a:ext cx="2084832" cy="292608"/>
           </a:xfrm>
           <a:prstGeom prst="roundRect">
@@ -5811,7 +5813,7 @@
         </p:nvSpPr>
         <p:spPr>
           <a:xfrm>
-            <a:off x="9153144" y="1399032"/>
+            <a:off x="9153144" y="1481328"/>
             <a:ext cx="1901952" cy="256032"/>
           </a:xfrm>
           <a:prstGeom prst="rect">
@@ -5847,47 +5849,6 @@
       <p:sp>
         <p:nvSpPr>
           <p:cNvPr id="28" name="Text 26"/>
-          <p:cNvSpPr/>
-          <p:nvPr/>
-        </p:nvSpPr>
-        <p:spPr>
-          <a:xfrm>
-            <a:off x="8577072" y="932688"/>
-            <a:ext cx="3063240" cy="402336"/>
-          </a:xfrm>
-          <a:prstGeom prst="rect">
-            <a:avLst/>
-          </a:prstGeom>
-          <a:noFill/>
-          <a:ln/>
-        </p:spPr>
-        <p:txBody>
-          <a:bodyPr wrap="square" lIns="0" tIns="0" rIns="0" bIns="0" rtlCol="0" anchor="ctr">
-            <a:normAutofit/>
-          </a:bodyPr>
-          <a:lstStyle/>
-          <a:p>
-            <a:pPr algn="r" indent="0" marL="0">
-              <a:buNone/>
-            </a:pPr>
-            <a:r>
-              <a:rPr lang="en-US" sz="850" dirty="0">
-                <a:solidFill>
-                  <a:srgbClr val="6D726D"/>
-                </a:solidFill>
-                <a:latin typeface="Inter" pitchFamily="34" charset="0"/>
-                <a:ea typeface="Inter" pitchFamily="34" charset="-122"/>
-                <a:cs typeface="Inter" pitchFamily="34" charset="-120"/>
-              </a:rPr>
-              <a:t>Turns hardware refresh into a measurable procurement-footprint story.</a:t>
-            </a:r>
-            <a:endParaRPr lang="en-US" sz="850" dirty="0"/>
-          </a:p>
-        </p:txBody>
-      </p:sp>
-      <p:sp>
-        <p:nvSpPr>
-          <p:cNvPr id="29" name="Text 27"/>
           <p:cNvSpPr/>
           <p:nvPr/>
         </p:nvSpPr>
@@ -6595,11 +6556,11 @@
           <p:nvPr/>
         </p:nvSpPr>
         <p:spPr>
-          <a:xfrm rot="600000">
+          <a:xfrm rot="2700000">
             <a:off x="8897112" y="2148840"/>
-            <a:ext cx="1097280" cy="914400"/>
-          </a:xfrm>
-          <a:prstGeom prst="arc">
+            <a:ext cx="914400" cy="1078992"/>
+          </a:xfrm>
+          <a:prstGeom prst="teardrop">
             <a:avLst/>
           </a:prstGeom>
           <a:solidFill>
@@ -6621,8 +6582,8 @@
         </p:nvSpPr>
         <p:spPr>
           <a:xfrm>
-            <a:off x="9061704" y="2834640"/>
-            <a:ext cx="731520" cy="-512064"/>
+            <a:off x="9098280" y="2889504"/>
+            <a:ext cx="566928" cy="-566928"/>
           </a:xfrm>
           <a:prstGeom prst="line">
             <a:avLst/>
@@ -8728,7 +8689,7 @@
         <p:spPr>
           <a:xfrm>
             <a:off x="6190488" y="5239512"/>
-            <a:ext cx="987552" cy="201168"/>
+            <a:ext cx="1234440" cy="201168"/>
           </a:xfrm>
           <a:prstGeom prst="rect">
             <a:avLst/>
@@ -8754,7 +8715,7 @@
                 <a:ea typeface="Inter" pitchFamily="34" charset="-122"/>
                 <a:cs typeface="Inter" pitchFamily="34" charset="-120"/>
               </a:rPr>
-              <a:t>ROI LOGIC</a:t>
+              <a:t>ROI  •  LOGIC</a:t>
             </a:r>
             <a:endParaRPr lang="en-US" sz="750" dirty="0"/>
           </a:p>

</xml_diff>